<commit_message>
Redesign all eleven slides with a Swiss typography grid for v7
</commit_message>
<xml_diff>
--- a/slides/slide-01.pptx
+++ b/slides/slide-01.pptx
@@ -4373,8 +4373,8 @@
         </p:nvSpPr>
         <p:spPr>
           <a:xfrm xmlns:a="http://schemas.openxmlformats.org/drawingml/2006/main">
-            <a:off x="609600" y="1428750"/>
-            <a:ext cx="10972800" cy="1009650"/>
+            <a:off x="609600" y="1219200"/>
+            <a:ext cx="8172450" cy="2362200"/>
           </a:xfrm>
           <a:prstGeom xmlns:a="http://schemas.openxmlformats.org/drawingml/2006/main" prst="rect">
             <a:avLst/>
@@ -4385,12 +4385,12 @@
           </a:ln>
         </p:spPr>
         <p:txBody>
-          <a:bodyPr xmlns:a="http://schemas.openxmlformats.org/drawingml/2006/main" wrap="none" lIns="0" tIns="0" rIns="0" bIns="0" anchor="ctr">
+          <a:bodyPr xmlns:a="http://schemas.openxmlformats.org/drawingml/2006/main" wrap="none" lIns="0" tIns="0" rIns="0" bIns="0" anchor="t">
             <a:noAutofit/>
           </a:bodyPr>
           <a:lstStyle xmlns:a="http://schemas.openxmlformats.org/drawingml/2006/main">
             <a:defPPr algn="l">
-              <a:defRPr sz="5400" b="1">
+              <a:defRPr sz="7200" b="1">
                 <a:solidFill>
                   <a:srgbClr val="F7F7F2"/>
                 </a:solidFill>
@@ -4505,7 +4505,7 @@
                 <a:spcPct val="115000"/>
               </a:lnSpc>
               <a:buNone/>
-              <a:defRPr sz="5400" b="1">
+              <a:defRPr sz="7200" b="1">
                 <a:solidFill>
                   <a:srgbClr val="F7F7F2"/>
                 </a:solidFill>
@@ -4515,7 +4515,7 @@
               </a:defRPr>
             </a:pPr>
             <a:r>
-              <a:rPr sz="5400" b="1">
+              <a:rPr sz="7200" b="1">
                 <a:solidFill>
                   <a:srgbClr val="F7F7F2"/>
                 </a:solidFill>
@@ -4523,7 +4523,34 @@
                 <a:ea typeface="HarmonyOS Sans SC"/>
                 <a:cs typeface="HarmonyOS Sans SC"/>
               </a:rPr>
-              <a:t>从你的创意到个性化硬件</a:t>
+              <a:t>从你的创意</a:t>
+            </a:r>
+          </a:p>
+          <a:p xmlns:a="http://schemas.openxmlformats.org/drawingml/2006/main">
+            <a:pPr algn="l">
+              <a:lnSpc>
+                <a:spcPct val="115000"/>
+              </a:lnSpc>
+              <a:buNone/>
+              <a:defRPr sz="7200" b="1">
+                <a:solidFill>
+                  <a:srgbClr val="F7F7F2"/>
+                </a:solidFill>
+                <a:latin typeface="HarmonyOS Sans SC"/>
+                <a:ea typeface="HarmonyOS Sans SC"/>
+                <a:cs typeface="HarmonyOS Sans SC"/>
+              </a:defRPr>
+            </a:pPr>
+            <a:r>
+              <a:rPr sz="7200" b="1">
+                <a:solidFill>
+                  <a:srgbClr val="F7F7F2"/>
+                </a:solidFill>
+                <a:latin typeface="HarmonyOS Sans SC"/>
+                <a:ea typeface="HarmonyOS Sans SC"/>
+                <a:cs typeface="HarmonyOS Sans SC"/>
+              </a:rPr>
+              <a:t>到个性化硬件</a:t>
             </a:r>
           </a:p>
         </p:txBody>
@@ -4544,8 +4571,8 @@
         </p:nvSpPr>
         <p:spPr>
           <a:xfrm xmlns:a="http://schemas.openxmlformats.org/drawingml/2006/main">
-            <a:off x="647700" y="2686050"/>
-            <a:ext cx="10858500" cy="514350"/>
+            <a:off x="9010650" y="1447800"/>
+            <a:ext cx="2571750" cy="1371600"/>
           </a:xfrm>
           <a:prstGeom xmlns:a="http://schemas.openxmlformats.org/drawingml/2006/main" prst="rect">
             <a:avLst/>
@@ -4556,12 +4583,12 @@
           </a:ln>
         </p:spPr>
         <p:txBody>
-          <a:bodyPr xmlns:a="http://schemas.openxmlformats.org/drawingml/2006/main" wrap="none" lIns="0" tIns="0" rIns="0" bIns="0" anchor="ctr">
+          <a:bodyPr xmlns:a="http://schemas.openxmlformats.org/drawingml/2006/main" wrap="none" lIns="0" tIns="0" rIns="0" bIns="0" anchor="t">
             <a:noAutofit/>
           </a:bodyPr>
           <a:lstStyle xmlns:a="http://schemas.openxmlformats.org/drawingml/2006/main">
             <a:defPPr algn="l">
-              <a:defRPr sz="2475" b="0">
+              <a:defRPr sz="1800" b="0">
                 <a:solidFill>
                   <a:srgbClr val="A6A7B2"/>
                 </a:solidFill>
@@ -4676,7 +4703,7 @@
                 <a:spcPct val="115000"/>
               </a:lnSpc>
               <a:buNone/>
-              <a:defRPr sz="2475" b="0">
+              <a:defRPr sz="1800" b="0">
                 <a:solidFill>
                   <a:srgbClr val="A6A7B2"/>
                 </a:solidFill>
@@ -4686,7 +4713,7 @@
               </a:defRPr>
             </a:pPr>
             <a:r>
-              <a:rPr sz="2475" b="0">
+              <a:rPr sz="1800" b="0">
                 <a:solidFill>
                   <a:srgbClr val="A6A7B2"/>
                 </a:solidFill>
@@ -4694,7 +4721,61 @@
                 <a:ea typeface="HarmonyOS Sans SC"/>
                 <a:cs typeface="HarmonyOS Sans SC"/>
               </a:rPr>
-              <a:t>From Your Ideas to Personalized Hardware</a:t>
+              <a:t>From Your Ideas</a:t>
+            </a:r>
+          </a:p>
+          <a:p xmlns:a="http://schemas.openxmlformats.org/drawingml/2006/main">
+            <a:pPr algn="l">
+              <a:lnSpc>
+                <a:spcPct val="115000"/>
+              </a:lnSpc>
+              <a:buNone/>
+              <a:defRPr sz="1800" b="0">
+                <a:solidFill>
+                  <a:srgbClr val="A6A7B2"/>
+                </a:solidFill>
+                <a:latin typeface="HarmonyOS Sans SC"/>
+                <a:ea typeface="HarmonyOS Sans SC"/>
+                <a:cs typeface="HarmonyOS Sans SC"/>
+              </a:defRPr>
+            </a:pPr>
+            <a:r>
+              <a:rPr sz="1800" b="0">
+                <a:solidFill>
+                  <a:srgbClr val="A6A7B2"/>
+                </a:solidFill>
+                <a:latin typeface="HarmonyOS Sans SC"/>
+                <a:ea typeface="HarmonyOS Sans SC"/>
+                <a:cs typeface="HarmonyOS Sans SC"/>
+              </a:rPr>
+              <a:t>to Personalized</a:t>
+            </a:r>
+          </a:p>
+          <a:p xmlns:a="http://schemas.openxmlformats.org/drawingml/2006/main">
+            <a:pPr algn="l">
+              <a:lnSpc>
+                <a:spcPct val="115000"/>
+              </a:lnSpc>
+              <a:buNone/>
+              <a:defRPr sz="1800" b="0">
+                <a:solidFill>
+                  <a:srgbClr val="A6A7B2"/>
+                </a:solidFill>
+                <a:latin typeface="HarmonyOS Sans SC"/>
+                <a:ea typeface="HarmonyOS Sans SC"/>
+                <a:cs typeface="HarmonyOS Sans SC"/>
+              </a:defRPr>
+            </a:pPr>
+            <a:r>
+              <a:rPr sz="1800" b="0">
+                <a:solidFill>
+                  <a:srgbClr val="A6A7B2"/>
+                </a:solidFill>
+                <a:latin typeface="HarmonyOS Sans SC"/>
+                <a:ea typeface="HarmonyOS Sans SC"/>
+                <a:cs typeface="HarmonyOS Sans SC"/>
+              </a:rPr>
+              <a:t>Hardware</a:t>
             </a:r>
           </a:p>
         </p:txBody>
@@ -4715,8 +4796,8 @@
         </p:nvSpPr>
         <p:spPr>
           <a:xfrm xmlns:a="http://schemas.openxmlformats.org/drawingml/2006/main">
-            <a:off x="647700" y="4191000"/>
-            <a:ext cx="10858500" cy="552450"/>
+            <a:off x="609600" y="4648200"/>
+            <a:ext cx="8172450" cy="533400"/>
           </a:xfrm>
           <a:prstGeom xmlns:a="http://schemas.openxmlformats.org/drawingml/2006/main" prst="rect">
             <a:avLst/>
@@ -4727,12 +4808,12 @@
           </a:ln>
         </p:spPr>
         <p:txBody>
-          <a:bodyPr xmlns:a="http://schemas.openxmlformats.org/drawingml/2006/main" wrap="none" lIns="0" tIns="0" rIns="0" bIns="0" anchor="ctr">
+          <a:bodyPr xmlns:a="http://schemas.openxmlformats.org/drawingml/2006/main" wrap="none" lIns="0" tIns="0" rIns="0" bIns="0" anchor="t">
             <a:noAutofit/>
           </a:bodyPr>
           <a:lstStyle xmlns:a="http://schemas.openxmlformats.org/drawingml/2006/main">
             <a:defPPr algn="l">
-              <a:defRPr sz="2550" b="1">
+              <a:defRPr sz="2400" b="1">
                 <a:solidFill>
                   <a:srgbClr val="65E8D4"/>
                 </a:solidFill>
@@ -4847,7 +4928,7 @@
                 <a:spcPct val="115000"/>
               </a:lnSpc>
               <a:buNone/>
-              <a:defRPr sz="2550" b="1">
+              <a:defRPr sz="2400" b="1">
                 <a:solidFill>
                   <a:srgbClr val="65E8D4"/>
                 </a:solidFill>
@@ -4857,7 +4938,7 @@
               </a:defRPr>
             </a:pPr>
             <a:r>
-              <a:rPr sz="2550" b="1">
+              <a:rPr sz="2400" b="1">
                 <a:solidFill>
                   <a:srgbClr val="65E8D4"/>
                 </a:solidFill>
@@ -4886,8 +4967,8 @@
         </p:nvSpPr>
         <p:spPr>
           <a:xfrm xmlns:a="http://schemas.openxmlformats.org/drawingml/2006/main">
-            <a:off x="647700" y="4810125"/>
-            <a:ext cx="10858500" cy="428625"/>
+            <a:off x="609600" y="5334000"/>
+            <a:ext cx="8172450" cy="381000"/>
           </a:xfrm>
           <a:prstGeom xmlns:a="http://schemas.openxmlformats.org/drawingml/2006/main" prst="rect">
             <a:avLst/>
@@ -4898,12 +4979,12 @@
           </a:ln>
         </p:spPr>
         <p:txBody>
-          <a:bodyPr xmlns:a="http://schemas.openxmlformats.org/drawingml/2006/main" wrap="none" lIns="0" tIns="0" rIns="0" bIns="0" anchor="ctr">
+          <a:bodyPr xmlns:a="http://schemas.openxmlformats.org/drawingml/2006/main" wrap="none" lIns="0" tIns="0" rIns="0" bIns="0" anchor="t">
             <a:noAutofit/>
           </a:bodyPr>
           <a:lstStyle xmlns:a="http://schemas.openxmlformats.org/drawingml/2006/main">
             <a:defPPr algn="l">
-              <a:defRPr sz="2025" b="0">
+              <a:defRPr sz="1800" b="0">
                 <a:solidFill>
                   <a:srgbClr val="A6A7B2"/>
                 </a:solidFill>
@@ -5018,7 +5099,7 @@
                 <a:spcPct val="115000"/>
               </a:lnSpc>
               <a:buNone/>
-              <a:defRPr sz="2025" b="0">
+              <a:defRPr sz="1800" b="0">
                 <a:solidFill>
                   <a:srgbClr val="A6A7B2"/>
                 </a:solidFill>
@@ -5028,7 +5109,7 @@
               </a:defRPr>
             </a:pPr>
             <a:r>
-              <a:rPr sz="2025" b="0">
+              <a:rPr sz="1800" b="0">
                 <a:solidFill>
                   <a:srgbClr val="A6A7B2"/>
                 </a:solidFill>
@@ -5067,7 +5148,7 @@
         </p:blipFill>
         <p:spPr>
           <a:xfrm xmlns:a="http://schemas.openxmlformats.org/drawingml/2006/main">
-            <a:off x="609600" y="6524625"/>
+            <a:off x="609600" y="6400800"/>
             <a:ext cx="1952625" cy="228220"/>
           </a:xfrm>
           <a:prstGeom xmlns:a="http://schemas.openxmlformats.org/drawingml/2006/main" prst="rect">
@@ -5091,8 +5172,8 @@
         </p:nvSpPr>
         <p:spPr>
           <a:xfrm xmlns:a="http://schemas.openxmlformats.org/drawingml/2006/main">
-            <a:off x="11191875" y="6505575"/>
-            <a:ext cx="419100" cy="247650"/>
+            <a:off x="11163300" y="6400800"/>
+            <a:ext cx="419100" cy="228600"/>
           </a:xfrm>
           <a:prstGeom xmlns:a="http://schemas.openxmlformats.org/drawingml/2006/main" prst="rect">
             <a:avLst/>
@@ -5103,7 +5184,7 @@
           </a:ln>
         </p:spPr>
         <p:txBody>
-          <a:bodyPr xmlns:a="http://schemas.openxmlformats.org/drawingml/2006/main" wrap="none" lIns="0" tIns="0" rIns="0" bIns="0" anchor="ctr">
+          <a:bodyPr xmlns:a="http://schemas.openxmlformats.org/drawingml/2006/main" wrap="none" lIns="0" tIns="0" rIns="0" bIns="0" anchor="t">
             <a:noAutofit/>
           </a:bodyPr>
           <a:lstStyle xmlns:a="http://schemas.openxmlformats.org/drawingml/2006/main">

</xml_diff>